<commit_message>
feat(matching): add mailto launcher, P0/P1/P2 roadmap improvements, and safe IMAP sync
</commit_message>
<xml_diff>
--- a/exports/knowledge_flow/mighty_skill_bridge_ceo_presentation_2026-06-02_figma-modern.pptx
+++ b/exports/knowledge_flow/mighty_skill_bridge_ceo_presentation_2026-06-02_figma-modern.pptx
@@ -3285,7 +3285,7 @@
                 </a:solidFill>
                 <a:latin typeface="Consolas"/>
               </a:rPr>
-              <a:t>01 / 08   |   NotebookLM CLI outline · ID: 4934c12b...</a:t>
+              <a:t>01 / 08   |   NotebookLM CLI outline · ID: 75521ea6...</a:t>
             </a:r>
           </a:p>
         </p:txBody>
@@ -4529,7 +4529,7 @@
                 </a:solidFill>
                 <a:latin typeface="Consolas"/>
               </a:rPr>
-              <a:t>02 / 08   |   NotebookLM CLI outline · ID: 4934c12b...</a:t>
+              <a:t>02 / 08   |   NotebookLM CLI outline · ID: 75521ea6...</a:t>
             </a:r>
           </a:p>
         </p:txBody>
@@ -5789,7 +5789,7 @@
                 </a:solidFill>
                 <a:latin typeface="Consolas"/>
               </a:rPr>
-              <a:t>03 / 08   |   NotebookLM CLI outline · ID: 4934c12b...</a:t>
+              <a:t>03 / 08   |   NotebookLM CLI outline · ID: 75521ea6...</a:t>
             </a:r>
           </a:p>
         </p:txBody>
@@ -7315,7 +7315,7 @@
                 </a:solidFill>
                 <a:latin typeface="Consolas"/>
               </a:rPr>
-              <a:t>•  NotebookLM sources ready: 160</a:t>
+              <a:t>•  NotebookLM sources ready: 165</a:t>
             </a:r>
           </a:p>
           <a:p>
@@ -7544,7 +7544,7 @@
                 </a:solidFill>
                 <a:latin typeface="Consolas"/>
               </a:rPr>
-              <a:t>04 / 08   |   NotebookLM CLI outline · ID: 4934c12b...</a:t>
+              <a:t>04 / 08   |   NotebookLM CLI outline · ID: 75521ea6...</a:t>
             </a:r>
           </a:p>
         </p:txBody>
@@ -8888,7 +8888,7 @@
                 </a:solidFill>
                 <a:latin typeface="Consolas"/>
               </a:rPr>
-              <a:t>05 / 08   |   NotebookLM CLI outline · ID: 4934c12b...</a:t>
+              <a:t>05 / 08   |   NotebookLM CLI outline · ID: 75521ea6...</a:t>
             </a:r>
           </a:p>
         </p:txBody>
@@ -10168,7 +10168,7 @@
                 </a:solidFill>
                 <a:latin typeface="Consolas"/>
               </a:rPr>
-              <a:t>•  NotebookLM notebook: 4934c12b-b270-4739-97a1-b04b5b84eaaf</a:t>
+              <a:t>•  NotebookLM notebook: 75521ea6-6b9b-47b2-9508-50050d8ab2d5</a:t>
             </a:r>
           </a:p>
           <a:p>
@@ -10413,7 +10413,7 @@
                 </a:solidFill>
                 <a:latin typeface="Consolas"/>
               </a:rPr>
-              <a:t>06 / 08   |   NotebookLM CLI outline · ID: 4934c12b...</a:t>
+              <a:t>06 / 08   |   NotebookLM CLI outline · ID: 75521ea6...</a:t>
             </a:r>
           </a:p>
         </p:txBody>
@@ -11891,7 +11891,7 @@
                 </a:solidFill>
                 <a:latin typeface="Consolas"/>
               </a:rPr>
-              <a:t>07 / 08   |   NotebookLM CLI outline · ID: 4934c12b...</a:t>
+              <a:t>07 / 08   |   NotebookLM CLI outline · ID: 75521ea6...</a:t>
             </a:r>
           </a:p>
         </p:txBody>
@@ -13265,7 +13265,7 @@
                 </a:solidFill>
                 <a:latin typeface="Consolas"/>
               </a:rPr>
-              <a:t>08 / 08   |   NotebookLM CLI outline · ID: 4934c12b...</a:t>
+              <a:t>08 / 08   |   NotebookLM CLI outline · ID: 75521ea6...</a:t>
             </a:r>
           </a:p>
         </p:txBody>

</xml_diff>

<commit_message>
chore: refresh T850 sync artifacts
</commit_message>
<xml_diff>
--- a/exports/knowledge_flow/mighty_skill_bridge_ceo_presentation_2026-06-02_figma-modern.pptx
+++ b/exports/knowledge_flow/mighty_skill_bridge_ceo_presentation_2026-06-02_figma-modern.pptx
@@ -5114,7 +5114,7 @@
                 </a:solidFill>
                 <a:latin typeface="Plus Jakarta Sans"/>
               </a:rPr>
-              <a:t>418 Tasks</a:t>
+              <a:t>429 Tasks</a:t>
             </a:r>
           </a:p>
         </p:txBody>
@@ -7315,7 +7315,7 @@
                 </a:solidFill>
                 <a:latin typeface="Consolas"/>
               </a:rPr>
-              <a:t>•  NotebookLM sources ready: 165</a:t>
+              <a:t>•  NotebookLM sources ready: 169</a:t>
             </a:r>
           </a:p>
           <a:p>

</xml_diff>

<commit_message>
feat(sales-email): integrate realtime IMAP IDLE ingestion daemon and alert pipeline
</commit_message>
<xml_diff>
--- a/exports/knowledge_flow/mighty_skill_bridge_ceo_presentation_2026-06-02_figma-modern.pptx
+++ b/exports/knowledge_flow/mighty_skill_bridge_ceo_presentation_2026-06-02_figma-modern.pptx
@@ -5114,7 +5114,7 @@
                 </a:solidFill>
                 <a:latin typeface="Plus Jakarta Sans"/>
               </a:rPr>
-              <a:t>417 Tasks</a:t>
+              <a:t>429 Tasks</a:t>
             </a:r>
           </a:p>
         </p:txBody>
@@ -7315,7 +7315,7 @@
                 </a:solidFill>
                 <a:latin typeface="Consolas"/>
               </a:rPr>
-              <a:t>•  NotebookLM sources ready: 165</a:t>
+              <a:t>•  NotebookLM sources ready: 169</a:t>
             </a:r>
           </a:p>
           <a:p>

</xml_diff>